<commit_message>
Expansion auto-close fix, sort improvements, refactor of home page
</commit_message>
<xml_diff>
--- a/AdminInterface/UserGuide.pptx
+++ b/AdminInterface/UserGuide.pptx
@@ -634,6 +634,90 @@
 </file>
 
 <file path=ppt/notesSlides/notesSlide1.xml><?xml version="1.0" encoding="utf-8"?>
+<p:notes xmlns:a="http://schemas.openxmlformats.org/drawingml/2006/main" xmlns:r="http://schemas.openxmlformats.org/officeDocument/2006/relationships" xmlns:p="http://schemas.openxmlformats.org/presentationml/2006/main">
+  <p:cSld>
+    <p:spTree>
+      <p:nvGrpSpPr>
+        <p:cNvPr id="1" name=""/>
+        <p:cNvGrpSpPr/>
+        <p:nvPr/>
+      </p:nvGrpSpPr>
+      <p:grpSpPr>
+        <a:xfrm>
+          <a:off x="0" y="0"/>
+          <a:ext cx="0" cy="0"/>
+          <a:chOff x="0" y="0"/>
+          <a:chExt cx="0" cy="0"/>
+        </a:xfrm>
+      </p:grpSpPr>
+      <p:sp>
+        <p:nvSpPr>
+          <p:cNvPr id="2" name="Slide Image Placeholder 1"/>
+          <p:cNvSpPr>
+            <a:spLocks noGrp="1" noRot="1" noChangeAspect="1"/>
+          </p:cNvSpPr>
+          <p:nvPr>
+            <p:ph type="sldImg"/>
+          </p:nvPr>
+        </p:nvSpPr>
+        <p:spPr/>
+      </p:sp>
+      <p:sp>
+        <p:nvSpPr>
+          <p:cNvPr id="3" name="Notes Placeholder 2"/>
+          <p:cNvSpPr>
+            <a:spLocks noGrp="1"/>
+          </p:cNvSpPr>
+          <p:nvPr>
+            <p:ph type="body" idx="1"/>
+          </p:nvPr>
+        </p:nvSpPr>
+        <p:spPr/>
+        <p:txBody>
+          <a:bodyPr/>
+          <a:lstStyle/>
+          <a:p>
+            <a:endParaRPr lang="en-US" dirty="0"/>
+          </a:p>
+        </p:txBody>
+      </p:sp>
+      <p:sp>
+        <p:nvSpPr>
+          <p:cNvPr id="4" name="Slide Number Placeholder 3"/>
+          <p:cNvSpPr>
+            <a:spLocks noGrp="1"/>
+          </p:cNvSpPr>
+          <p:nvPr>
+            <p:ph type="sldNum" sz="quarter" idx="5"/>
+          </p:nvPr>
+        </p:nvSpPr>
+        <p:spPr/>
+        <p:txBody>
+          <a:bodyPr/>
+          <a:lstStyle/>
+          <a:p>
+            <a:fld id="{F91CF8D7-B076-43C3-BFB0-F1A9323A501F}" type="slidenum">
+              <a:rPr lang="en-US" smtClean="0"/>
+              <a:t>7</a:t>
+            </a:fld>
+            <a:endParaRPr lang="en-US"/>
+          </a:p>
+        </p:txBody>
+      </p:sp>
+    </p:spTree>
+    <p:extLst>
+      <p:ext uri="{BB962C8B-B14F-4D97-AF65-F5344CB8AC3E}">
+        <p14:creationId xmlns:p14="http://schemas.microsoft.com/office/powerpoint/2010/main" val="3767727823"/>
+      </p:ext>
+    </p:extLst>
+  </p:cSld>
+  <p:clrMapOvr>
+    <a:masterClrMapping/>
+  </p:clrMapOvr>
+</p:notes>
+</file>
+
+<file path=ppt/notesSlides/notesSlide2.xml><?xml version="1.0" encoding="utf-8"?>
 <p:notes xmlns:a="http://schemas.openxmlformats.org/drawingml/2006/main" xmlns:r="http://schemas.openxmlformats.org/officeDocument/2006/relationships" xmlns:p="http://schemas.openxmlformats.org/presentationml/2006/main">
   <p:cSld>
     <p:spTree>
@@ -6985,10 +7069,10 @@
       </p:grpSpPr>
       <p:pic>
         <p:nvPicPr>
-          <p:cNvPr id="9" name="Picture 8">
-            <a:extLst>
-              <a:ext uri="{FF2B5EF4-FFF2-40B4-BE49-F238E27FC236}">
-                <a16:creationId xmlns:a16="http://schemas.microsoft.com/office/drawing/2014/main" id="{F1782F16-F5F5-7B14-C132-7ECBCED1E2BE}"/>
+          <p:cNvPr id="11" name="Picture 10">
+            <a:extLst>
+              <a:ext uri="{FF2B5EF4-FFF2-40B4-BE49-F238E27FC236}">
+                <a16:creationId xmlns:a16="http://schemas.microsoft.com/office/drawing/2014/main" id="{B09800A6-6BA8-1E2C-E1DD-699C923D2DF4}"/>
               </a:ext>
             </a:extLst>
           </p:cNvPr>
@@ -6999,15 +7083,14 @@
         </p:nvPicPr>
         <p:blipFill>
           <a:blip r:embed="rId2"/>
-          <a:srcRect r="170"/>
           <a:stretch>
             <a:fillRect/>
           </a:stretch>
         </p:blipFill>
         <p:spPr>
           <a:xfrm>
-            <a:off x="308257" y="896378"/>
-            <a:ext cx="11426544" cy="5687180"/>
+            <a:off x="293204" y="896377"/>
+            <a:ext cx="11546862" cy="5731113"/>
           </a:xfrm>
           <a:prstGeom prst="rect">
             <a:avLst/>
@@ -7505,7 +7588,7 @@
         </p:nvSpPr>
         <p:spPr>
           <a:xfrm>
-            <a:off x="3826145" y="1307470"/>
+            <a:off x="3851062" y="1330060"/>
             <a:ext cx="1258829" cy="246221"/>
           </a:xfrm>
           <a:prstGeom prst="rect">
@@ -7529,6 +7612,61 @@
                 </a:solidFill>
               </a:rPr>
               <a:t>Locked vs released</a:t>
+            </a:r>
+          </a:p>
+        </p:txBody>
+      </p:sp>
+      <p:sp>
+        <p:nvSpPr>
+          <p:cNvPr id="12" name="TextBox 11">
+            <a:extLst>
+              <a:ext uri="{FF2B5EF4-FFF2-40B4-BE49-F238E27FC236}">
+                <a16:creationId xmlns:a16="http://schemas.microsoft.com/office/drawing/2014/main" id="{72D9A32D-2C6F-F504-272C-A9E0F5E489B7}"/>
+              </a:ext>
+            </a:extLst>
+          </p:cNvPr>
+          <p:cNvSpPr txBox="1"/>
+          <p:nvPr/>
+        </p:nvSpPr>
+        <p:spPr>
+          <a:xfrm>
+            <a:off x="11736073" y="1343024"/>
+            <a:ext cx="553998" cy="5179046"/>
+          </a:xfrm>
+          <a:prstGeom prst="rect">
+            <a:avLst/>
+          </a:prstGeom>
+          <a:noFill/>
+        </p:spPr>
+        <p:txBody>
+          <a:bodyPr vert="eaVert" wrap="none" rtlCol="0">
+            <a:spAutoFit/>
+          </a:bodyPr>
+          <a:lstStyle/>
+          <a:p>
+            <a:r>
+              <a:rPr lang="en-US" sz="1200" dirty="0">
+                <a:solidFill>
+                  <a:schemeClr val="accent5">
+                    <a:lumMod val="60000"/>
+                    <a:lumOff val="40000"/>
+                  </a:schemeClr>
+                </a:solidFill>
+              </a:rPr>
+              <a:t>When there are more results than fit on the screen,</a:t>
+            </a:r>
+          </a:p>
+          <a:p>
+            <a:r>
+              <a:rPr lang="en-US" sz="1200" dirty="0">
+                <a:solidFill>
+                  <a:schemeClr val="accent5">
+                    <a:lumMod val="60000"/>
+                    <a:lumOff val="40000"/>
+                  </a:schemeClr>
+                </a:solidFill>
+              </a:rPr>
+              <a:t>use the outer one to navigate the page and the inner one to navigate the table</a:t>
             </a:r>
           </a:p>
         </p:txBody>
@@ -7571,10 +7709,10 @@
       </p:grpSpPr>
       <p:pic>
         <p:nvPicPr>
-          <p:cNvPr id="4" name="Picture 3">
-            <a:extLst>
-              <a:ext uri="{FF2B5EF4-FFF2-40B4-BE49-F238E27FC236}">
-                <a16:creationId xmlns:a16="http://schemas.microsoft.com/office/drawing/2014/main" id="{20727CC1-9167-6CD7-9D0A-49E428767A36}"/>
+          <p:cNvPr id="5" name="Picture 4">
+            <a:extLst>
+              <a:ext uri="{FF2B5EF4-FFF2-40B4-BE49-F238E27FC236}">
+                <a16:creationId xmlns:a16="http://schemas.microsoft.com/office/drawing/2014/main" id="{97DFF277-3D7C-8B60-B6AC-9A6246A62CB6}"/>
               </a:ext>
             </a:extLst>
           </p:cNvPr>
@@ -7592,7 +7730,7 @@
         <p:spPr>
           <a:xfrm>
             <a:off x="301657" y="932859"/>
-            <a:ext cx="11585543" cy="5845014"/>
+            <a:ext cx="11585543" cy="5795807"/>
           </a:xfrm>
           <a:prstGeom prst="rect">
             <a:avLst/>
@@ -7835,10 +7973,10 @@
       </p:grpSpPr>
       <p:pic>
         <p:nvPicPr>
-          <p:cNvPr id="5" name="Picture 4">
-            <a:extLst>
-              <a:ext uri="{FF2B5EF4-FFF2-40B4-BE49-F238E27FC236}">
-                <a16:creationId xmlns:a16="http://schemas.microsoft.com/office/drawing/2014/main" id="{FC481DE7-9980-B5F1-0956-05D16251491E}"/>
+          <p:cNvPr id="6" name="Picture 5">
+            <a:extLst>
+              <a:ext uri="{FF2B5EF4-FFF2-40B4-BE49-F238E27FC236}">
+                <a16:creationId xmlns:a16="http://schemas.microsoft.com/office/drawing/2014/main" id="{43D24C7C-13B5-1A56-121B-9EDEDD100422}"/>
               </a:ext>
             </a:extLst>
           </p:cNvPr>
@@ -7855,8 +7993,8 @@
         </p:blipFill>
         <p:spPr>
           <a:xfrm>
-            <a:off x="292231" y="921581"/>
-            <a:ext cx="11729583" cy="5711263"/>
+            <a:off x="278342" y="907749"/>
+            <a:ext cx="11486310" cy="5725095"/>
           </a:xfrm>
           <a:prstGeom prst="rect">
             <a:avLst/>
@@ -7907,7 +8045,7 @@
         </p:nvSpPr>
         <p:spPr>
           <a:xfrm>
-            <a:off x="1729361" y="2905779"/>
+            <a:off x="1729361" y="2845355"/>
             <a:ext cx="1904682" cy="246221"/>
           </a:xfrm>
           <a:prstGeom prst="rect">
@@ -7949,7 +8087,7 @@
         </p:nvSpPr>
         <p:spPr>
           <a:xfrm>
-            <a:off x="3634043" y="2968466"/>
+            <a:off x="3634043" y="2968465"/>
             <a:ext cx="762442" cy="400110"/>
           </a:xfrm>
           <a:prstGeom prst="rect">
@@ -7991,7 +8129,7 @@
         </p:nvSpPr>
         <p:spPr>
           <a:xfrm>
-            <a:off x="9452168" y="2845355"/>
+            <a:off x="9452168" y="2845354"/>
             <a:ext cx="1470274" cy="246221"/>
           </a:xfrm>
           <a:prstGeom prst="rect">
@@ -8097,6 +8235,36 @@
           <a:chExt cx="0" cy="0"/>
         </a:xfrm>
       </p:grpSpPr>
+      <p:pic>
+        <p:nvPicPr>
+          <p:cNvPr id="8" name="Picture 7">
+            <a:extLst>
+              <a:ext uri="{FF2B5EF4-FFF2-40B4-BE49-F238E27FC236}">
+                <a16:creationId xmlns:a16="http://schemas.microsoft.com/office/drawing/2014/main" id="{C462799C-5083-1D2B-1656-A30074633406}"/>
+              </a:ext>
+            </a:extLst>
+          </p:cNvPr>
+          <p:cNvPicPr>
+            <a:picLocks noChangeAspect="1"/>
+          </p:cNvPicPr>
+          <p:nvPr/>
+        </p:nvPicPr>
+        <p:blipFill>
+          <a:blip r:embed="rId3"/>
+          <a:stretch>
+            <a:fillRect/>
+          </a:stretch>
+        </p:blipFill>
+        <p:spPr>
+          <a:xfrm>
+            <a:off x="295274" y="902009"/>
+            <a:ext cx="11591925" cy="5777718"/>
+          </a:xfrm>
+          <a:prstGeom prst="rect">
+            <a:avLst/>
+          </a:prstGeom>
+        </p:spPr>
+      </p:pic>
       <p:sp>
         <p:nvSpPr>
           <p:cNvPr id="2" name="Title 1">
@@ -8122,7 +8290,133 @@
           <a:p>
             <a:r>
               <a:rPr lang="en-US" dirty="0"/>
-              <a:t>Historical: the ‘more’ button</a:t>
+              <a:t>Historical: the ‘expand’ button</a:t>
+            </a:r>
+          </a:p>
+        </p:txBody>
+      </p:sp>
+      <p:sp>
+        <p:nvSpPr>
+          <p:cNvPr id="5" name="TextBox 4">
+            <a:extLst>
+              <a:ext uri="{FF2B5EF4-FFF2-40B4-BE49-F238E27FC236}">
+                <a16:creationId xmlns:a16="http://schemas.microsoft.com/office/drawing/2014/main" id="{4A281846-F328-178E-9A2C-71311D73239A}"/>
+              </a:ext>
+            </a:extLst>
+          </p:cNvPr>
+          <p:cNvSpPr txBox="1"/>
+          <p:nvPr/>
+        </p:nvSpPr>
+        <p:spPr>
+          <a:xfrm>
+            <a:off x="4152900" y="905060"/>
+            <a:ext cx="3886200" cy="400110"/>
+          </a:xfrm>
+          <a:prstGeom prst="rect">
+            <a:avLst/>
+          </a:prstGeom>
+          <a:noFill/>
+        </p:spPr>
+        <p:txBody>
+          <a:bodyPr wrap="square" rtlCol="0">
+            <a:spAutoFit/>
+          </a:bodyPr>
+          <a:lstStyle/>
+          <a:p>
+            <a:r>
+              <a:rPr lang="en-US" sz="1000" dirty="0">
+                <a:solidFill>
+                  <a:schemeClr val="accent5">
+                    <a:lumMod val="60000"/>
+                    <a:lumOff val="40000"/>
+                  </a:schemeClr>
+                </a:solidFill>
+              </a:rPr>
+              <a:t>Clicking the three lines next to an entry will highlight the row in blue and open a split screen of all attempted resets for that lockout.</a:t>
+            </a:r>
+          </a:p>
+        </p:txBody>
+      </p:sp>
+      <p:sp>
+        <p:nvSpPr>
+          <p:cNvPr id="6" name="TextBox 5">
+            <a:extLst>
+              <a:ext uri="{FF2B5EF4-FFF2-40B4-BE49-F238E27FC236}">
+                <a16:creationId xmlns:a16="http://schemas.microsoft.com/office/drawing/2014/main" id="{E1D613EC-5703-4E8E-A21C-ADCC9671805D}"/>
+              </a:ext>
+            </a:extLst>
+          </p:cNvPr>
+          <p:cNvSpPr txBox="1"/>
+          <p:nvPr/>
+        </p:nvSpPr>
+        <p:spPr>
+          <a:xfrm>
+            <a:off x="8150368" y="3028890"/>
+            <a:ext cx="3659854" cy="400110"/>
+          </a:xfrm>
+          <a:prstGeom prst="rect">
+            <a:avLst/>
+          </a:prstGeom>
+          <a:noFill/>
+        </p:spPr>
+        <p:txBody>
+          <a:bodyPr wrap="square" rtlCol="0">
+            <a:spAutoFit/>
+          </a:bodyPr>
+          <a:lstStyle/>
+          <a:p>
+            <a:r>
+              <a:rPr lang="en-US" sz="1000" dirty="0">
+                <a:solidFill>
+                  <a:schemeClr val="accent5">
+                    <a:lumMod val="60000"/>
+                    <a:lumOff val="40000"/>
+                  </a:schemeClr>
+                </a:solidFill>
+              </a:rPr>
+              <a:t>If the lockout has a paired reset, it’s highlighted in green and at the top (default sort is by auth state)</a:t>
+            </a:r>
+          </a:p>
+        </p:txBody>
+      </p:sp>
+      <p:sp>
+        <p:nvSpPr>
+          <p:cNvPr id="11" name="TextBox 10">
+            <a:extLst>
+              <a:ext uri="{FF2B5EF4-FFF2-40B4-BE49-F238E27FC236}">
+                <a16:creationId xmlns:a16="http://schemas.microsoft.com/office/drawing/2014/main" id="{88518FBE-206F-5E50-C6FF-0E23CCC9773E}"/>
+              </a:ext>
+            </a:extLst>
+          </p:cNvPr>
+          <p:cNvSpPr txBox="1"/>
+          <p:nvPr/>
+        </p:nvSpPr>
+        <p:spPr>
+          <a:xfrm>
+            <a:off x="9248140" y="3429000"/>
+            <a:ext cx="2562082" cy="400110"/>
+          </a:xfrm>
+          <a:prstGeom prst="rect">
+            <a:avLst/>
+          </a:prstGeom>
+          <a:noFill/>
+        </p:spPr>
+        <p:txBody>
+          <a:bodyPr wrap="square" rtlCol="0">
+            <a:spAutoFit/>
+          </a:bodyPr>
+          <a:lstStyle/>
+          <a:p>
+            <a:r>
+              <a:rPr lang="en-US" sz="1000" dirty="0">
+                <a:solidFill>
+                  <a:schemeClr val="accent5">
+                    <a:lumMod val="60000"/>
+                    <a:lumOff val="40000"/>
+                  </a:schemeClr>
+                </a:solidFill>
+              </a:rPr>
+              <a:t>Can filter denied requests by insufficient auth level or no privileges on target line</a:t>
             </a:r>
           </a:p>
         </p:txBody>

</xml_diff>

<commit_message>
Style and visibility changes
</commit_message>
<xml_diff>
--- a/AdminInterface/UserGuide.pptx
+++ b/AdminInterface/UserGuide.pptx
@@ -366,7 +366,7 @@
           <a:p>
             <a:fld id="{FA90DC49-5E56-4663-BD73-6254BEC8D958}" type="datetimeFigureOut">
               <a:rPr lang="en-US" smtClean="0"/>
-              <a:t>3/24/2026</a:t>
+              <a:t>3/25/2026</a:t>
             </a:fld>
             <a:endParaRPr lang="en-US"/>
           </a:p>
@@ -948,7 +948,7 @@
           <a:p>
             <a:fld id="{059A6F5A-3024-43F4-A20E-288FCAB0A2E6}" type="datetimeFigureOut">
               <a:rPr lang="en-US" smtClean="0"/>
-              <a:t>3/24/2026</a:t>
+              <a:t>3/25/2026</a:t>
             </a:fld>
             <a:endParaRPr lang="en-US"/>
           </a:p>
@@ -1146,7 +1146,7 @@
           <a:p>
             <a:fld id="{059A6F5A-3024-43F4-A20E-288FCAB0A2E6}" type="datetimeFigureOut">
               <a:rPr lang="en-US" smtClean="0"/>
-              <a:t>3/24/2026</a:t>
+              <a:t>3/25/2026</a:t>
             </a:fld>
             <a:endParaRPr lang="en-US"/>
           </a:p>
@@ -1421,7 +1421,7 @@
           <a:p>
             <a:fld id="{059A6F5A-3024-43F4-A20E-288FCAB0A2E6}" type="datetimeFigureOut">
               <a:rPr lang="en-US" smtClean="0"/>
-              <a:t>3/24/2026</a:t>
+              <a:t>3/25/2026</a:t>
             </a:fld>
             <a:endParaRPr lang="en-US"/>
           </a:p>
@@ -1692,7 +1692,7 @@
           <a:p>
             <a:fld id="{059A6F5A-3024-43F4-A20E-288FCAB0A2E6}" type="datetimeFigureOut">
               <a:rPr lang="en-US" smtClean="0"/>
-              <a:t>3/24/2026</a:t>
+              <a:t>3/25/2026</a:t>
             </a:fld>
             <a:endParaRPr lang="en-US"/>
           </a:p>
@@ -2105,7 +2105,7 @@
           <a:p>
             <a:fld id="{059A6F5A-3024-43F4-A20E-288FCAB0A2E6}" type="datetimeFigureOut">
               <a:rPr lang="en-US" smtClean="0"/>
-              <a:t>3/24/2026</a:t>
+              <a:t>3/25/2026</a:t>
             </a:fld>
             <a:endParaRPr lang="en-US"/>
           </a:p>
@@ -2246,7 +2246,7 @@
           <a:p>
             <a:fld id="{059A6F5A-3024-43F4-A20E-288FCAB0A2E6}" type="datetimeFigureOut">
               <a:rPr lang="en-US" smtClean="0"/>
-              <a:t>3/24/2026</a:t>
+              <a:t>3/25/2026</a:t>
             </a:fld>
             <a:endParaRPr lang="en-US"/>
           </a:p>
@@ -2911,7 +2911,7 @@
           <a:p>
             <a:fld id="{059A6F5A-3024-43F4-A20E-288FCAB0A2E6}" type="datetimeFigureOut">
               <a:rPr lang="en-US" smtClean="0"/>
-              <a:t>3/24/2026</a:t>
+              <a:t>3/25/2026</a:t>
             </a:fld>
             <a:endParaRPr lang="en-US"/>
           </a:p>
@@ -3152,7 +3152,7 @@
           <a:p>
             <a:fld id="{059A6F5A-3024-43F4-A20E-288FCAB0A2E6}" type="datetimeFigureOut">
               <a:rPr lang="en-US" smtClean="0"/>
-              <a:t>3/24/2026</a:t>
+              <a:t>3/25/2026</a:t>
             </a:fld>
             <a:endParaRPr lang="en-US"/>
           </a:p>
@@ -8195,6 +8195,48 @@
                 </a:solidFill>
               </a:rPr>
               <a:t>Click any column header to cycle through sort directions for that attribute. You can only sort by one column at once, and the default sort is by most recent lockout time.</a:t>
+            </a:r>
+          </a:p>
+        </p:txBody>
+      </p:sp>
+      <p:sp>
+        <p:nvSpPr>
+          <p:cNvPr id="4" name="TextBox 3">
+            <a:extLst>
+              <a:ext uri="{FF2B5EF4-FFF2-40B4-BE49-F238E27FC236}">
+                <a16:creationId xmlns:a16="http://schemas.microsoft.com/office/drawing/2014/main" id="{F33FD550-8542-DEDD-FCED-49A50F2F22E6}"/>
+              </a:ext>
+            </a:extLst>
+          </p:cNvPr>
+          <p:cNvSpPr txBox="1"/>
+          <p:nvPr/>
+        </p:nvSpPr>
+        <p:spPr>
+          <a:xfrm>
+            <a:off x="4015264" y="905060"/>
+            <a:ext cx="5316983" cy="400110"/>
+          </a:xfrm>
+          <a:prstGeom prst="rect">
+            <a:avLst/>
+          </a:prstGeom>
+          <a:noFill/>
+        </p:spPr>
+        <p:txBody>
+          <a:bodyPr wrap="square" rtlCol="0">
+            <a:spAutoFit/>
+          </a:bodyPr>
+          <a:lstStyle/>
+          <a:p>
+            <a:r>
+              <a:rPr lang="en-US" sz="1000" dirty="0">
+                <a:solidFill>
+                  <a:schemeClr val="accent5">
+                    <a:lumMod val="60000"/>
+                    <a:lumOff val="40000"/>
+                  </a:schemeClr>
+                </a:solidFill>
+              </a:rPr>
+              <a:t>Sorting assumes you only want to see entries where that value exists. For example, sorting by reset time here would hide all entries except the ones reset by ‘b’ and ‘eh’, then apply the sort</a:t>
             </a:r>
           </a:p>
         </p:txBody>

</xml_diff>

<commit_message>
Filter panel now collapsible, simplified filter class
</commit_message>
<xml_diff>
--- a/AdminInterface/UserGuide.pptx
+++ b/AdminInterface/UserGuide.pptx
@@ -7069,10 +7069,10 @@
       </p:grpSpPr>
       <p:pic>
         <p:nvPicPr>
-          <p:cNvPr id="11" name="Picture 10">
-            <a:extLst>
-              <a:ext uri="{FF2B5EF4-FFF2-40B4-BE49-F238E27FC236}">
-                <a16:creationId xmlns:a16="http://schemas.microsoft.com/office/drawing/2014/main" id="{B09800A6-6BA8-1E2C-E1DD-699C923D2DF4}"/>
+          <p:cNvPr id="4" name="Picture 3">
+            <a:extLst>
+              <a:ext uri="{FF2B5EF4-FFF2-40B4-BE49-F238E27FC236}">
+                <a16:creationId xmlns:a16="http://schemas.microsoft.com/office/drawing/2014/main" id="{E2737D05-7133-2C5D-6738-52E3A415A52B}"/>
               </a:ext>
             </a:extLst>
           </p:cNvPr>
@@ -7089,8 +7089,8 @@
         </p:blipFill>
         <p:spPr>
           <a:xfrm>
-            <a:off x="293204" y="896377"/>
-            <a:ext cx="11546862" cy="5731113"/>
+            <a:off x="293204" y="896378"/>
+            <a:ext cx="11546862" cy="5788568"/>
           </a:xfrm>
           <a:prstGeom prst="rect">
             <a:avLst/>
@@ -7287,7 +7287,7 @@
         </p:nvSpPr>
         <p:spPr>
           <a:xfrm>
-            <a:off x="7337718" y="985112"/>
+            <a:off x="6815901" y="1263945"/>
             <a:ext cx="3902044" cy="246221"/>
           </a:xfrm>
           <a:prstGeom prst="rect">
@@ -7351,7 +7351,7 @@
         </p:nvSpPr>
         <p:spPr>
           <a:xfrm>
-            <a:off x="7598879" y="2401699"/>
+            <a:off x="7671844" y="2737749"/>
             <a:ext cx="2821733" cy="400110"/>
           </a:xfrm>
           <a:prstGeom prst="rect">
@@ -7415,7 +7415,7 @@
         </p:nvSpPr>
         <p:spPr>
           <a:xfrm>
-            <a:off x="1912022" y="1224709"/>
+            <a:off x="2046977" y="1542999"/>
             <a:ext cx="1800421" cy="246221"/>
           </a:xfrm>
           <a:prstGeom prst="rect">
@@ -7457,7 +7457,7 @@
         </p:nvSpPr>
         <p:spPr>
           <a:xfrm rot="5400000">
-            <a:off x="8966296" y="-991327"/>
+            <a:off x="8981348" y="-655277"/>
             <a:ext cx="246222" cy="4577116"/>
           </a:xfrm>
           <a:prstGeom prst="leftBrace">
@@ -7504,7 +7504,7 @@
         </p:nvSpPr>
         <p:spPr>
           <a:xfrm>
-            <a:off x="2637808" y="2401699"/>
+            <a:off x="3442142" y="2758024"/>
             <a:ext cx="3910628" cy="400110"/>
           </a:xfrm>
           <a:prstGeom prst="rect">
@@ -7546,7 +7546,7 @@
         </p:nvSpPr>
         <p:spPr>
           <a:xfrm>
-            <a:off x="5109891" y="1219914"/>
+            <a:off x="5124943" y="1555964"/>
             <a:ext cx="1591869" cy="246221"/>
           </a:xfrm>
           <a:prstGeom prst="rect">
@@ -7588,7 +7588,7 @@
         </p:nvSpPr>
         <p:spPr>
           <a:xfrm>
-            <a:off x="3851062" y="1330060"/>
+            <a:off x="3866114" y="1666110"/>
             <a:ext cx="1258829" cy="246221"/>
           </a:xfrm>
           <a:prstGeom prst="rect">
@@ -7671,6 +7671,90 @@
           </a:p>
         </p:txBody>
       </p:sp>
+      <p:sp>
+        <p:nvSpPr>
+          <p:cNvPr id="5" name="TextBox 4">
+            <a:extLst>
+              <a:ext uri="{FF2B5EF4-FFF2-40B4-BE49-F238E27FC236}">
+                <a16:creationId xmlns:a16="http://schemas.microsoft.com/office/drawing/2014/main" id="{A2D898AF-51DE-2DB6-B8CC-44027DA797CB}"/>
+              </a:ext>
+            </a:extLst>
+          </p:cNvPr>
+          <p:cNvSpPr txBox="1"/>
+          <p:nvPr/>
+        </p:nvSpPr>
+        <p:spPr>
+          <a:xfrm>
+            <a:off x="9258835" y="896377"/>
+            <a:ext cx="2308325" cy="246221"/>
+          </a:xfrm>
+          <a:prstGeom prst="rect">
+            <a:avLst/>
+          </a:prstGeom>
+          <a:noFill/>
+        </p:spPr>
+        <p:txBody>
+          <a:bodyPr wrap="square" rtlCol="0">
+            <a:spAutoFit/>
+          </a:bodyPr>
+          <a:lstStyle/>
+          <a:p>
+            <a:r>
+              <a:rPr lang="en-US" sz="1000" dirty="0">
+                <a:solidFill>
+                  <a:schemeClr val="accent5">
+                    <a:lumMod val="60000"/>
+                    <a:lumOff val="40000"/>
+                  </a:schemeClr>
+                </a:solidFill>
+              </a:rPr>
+              <a:t>Hide the filters to free up screen space</a:t>
+            </a:r>
+          </a:p>
+        </p:txBody>
+      </p:sp>
+      <p:cxnSp>
+        <p:nvCxnSpPr>
+          <p:cNvPr id="9" name="Straight Arrow Connector 8">
+            <a:extLst>
+              <a:ext uri="{FF2B5EF4-FFF2-40B4-BE49-F238E27FC236}">
+                <a16:creationId xmlns:a16="http://schemas.microsoft.com/office/drawing/2014/main" id="{D367C251-3F5D-01AE-FD8C-7F4913BAAD76}"/>
+              </a:ext>
+            </a:extLst>
+          </p:cNvPr>
+          <p:cNvCxnSpPr>
+            <a:cxnSpLocks/>
+            <a:stCxn id="5" idx="2"/>
+          </p:cNvCxnSpPr>
+          <p:nvPr/>
+        </p:nvCxnSpPr>
+        <p:spPr>
+          <a:xfrm>
+            <a:off x="10412998" y="1142598"/>
+            <a:ext cx="610602" cy="244457"/>
+          </a:xfrm>
+          <a:prstGeom prst="straightConnector1">
+            <a:avLst/>
+          </a:prstGeom>
+          <a:ln>
+            <a:tailEnd type="triangle"/>
+          </a:ln>
+        </p:spPr>
+        <p:style>
+          <a:lnRef idx="2">
+            <a:schemeClr val="accent1"/>
+          </a:lnRef>
+          <a:fillRef idx="0">
+            <a:schemeClr val="accent1"/>
+          </a:fillRef>
+          <a:effectRef idx="1">
+            <a:schemeClr val="accent1"/>
+          </a:effectRef>
+          <a:fontRef idx="minor">
+            <a:schemeClr val="tx1"/>
+          </a:fontRef>
+        </p:style>
+      </p:cxnSp>
     </p:spTree>
     <p:extLst>
       <p:ext uri="{BB962C8B-B14F-4D97-AF65-F5344CB8AC3E}">

</xml_diff>

<commit_message>
Put the filter panel back where it belongs in SearchLockouts.razor. It's a little strange at first but with the new collapsible navbar, it's worth it to avoid @ref.
</commit_message>
<xml_diff>
--- a/AdminInterface/UserGuide.pptx
+++ b/AdminInterface/UserGuide.pptx
@@ -366,7 +366,7 @@
           <a:p>
             <a:fld id="{FA90DC49-5E56-4663-BD73-6254BEC8D958}" type="datetimeFigureOut">
               <a:rPr lang="en-US" smtClean="0"/>
-              <a:t>3/25/2026</a:t>
+              <a:t>3/26/2026</a:t>
             </a:fld>
             <a:endParaRPr lang="en-US"/>
           </a:p>
@@ -948,7 +948,7 @@
           <a:p>
             <a:fld id="{059A6F5A-3024-43F4-A20E-288FCAB0A2E6}" type="datetimeFigureOut">
               <a:rPr lang="en-US" smtClean="0"/>
-              <a:t>3/25/2026</a:t>
+              <a:t>3/26/2026</a:t>
             </a:fld>
             <a:endParaRPr lang="en-US"/>
           </a:p>
@@ -1146,7 +1146,7 @@
           <a:p>
             <a:fld id="{059A6F5A-3024-43F4-A20E-288FCAB0A2E6}" type="datetimeFigureOut">
               <a:rPr lang="en-US" smtClean="0"/>
-              <a:t>3/25/2026</a:t>
+              <a:t>3/26/2026</a:t>
             </a:fld>
             <a:endParaRPr lang="en-US"/>
           </a:p>
@@ -1421,7 +1421,7 @@
           <a:p>
             <a:fld id="{059A6F5A-3024-43F4-A20E-288FCAB0A2E6}" type="datetimeFigureOut">
               <a:rPr lang="en-US" smtClean="0"/>
-              <a:t>3/25/2026</a:t>
+              <a:t>3/26/2026</a:t>
             </a:fld>
             <a:endParaRPr lang="en-US"/>
           </a:p>
@@ -1692,7 +1692,7 @@
           <a:p>
             <a:fld id="{059A6F5A-3024-43F4-A20E-288FCAB0A2E6}" type="datetimeFigureOut">
               <a:rPr lang="en-US" smtClean="0"/>
-              <a:t>3/25/2026</a:t>
+              <a:t>3/26/2026</a:t>
             </a:fld>
             <a:endParaRPr lang="en-US"/>
           </a:p>
@@ -2105,7 +2105,7 @@
           <a:p>
             <a:fld id="{059A6F5A-3024-43F4-A20E-288FCAB0A2E6}" type="datetimeFigureOut">
               <a:rPr lang="en-US" smtClean="0"/>
-              <a:t>3/25/2026</a:t>
+              <a:t>3/26/2026</a:t>
             </a:fld>
             <a:endParaRPr lang="en-US"/>
           </a:p>
@@ -2246,7 +2246,7 @@
           <a:p>
             <a:fld id="{059A6F5A-3024-43F4-A20E-288FCAB0A2E6}" type="datetimeFigureOut">
               <a:rPr lang="en-US" smtClean="0"/>
-              <a:t>3/25/2026</a:t>
+              <a:t>3/26/2026</a:t>
             </a:fld>
             <a:endParaRPr lang="en-US"/>
           </a:p>
@@ -2911,7 +2911,7 @@
           <a:p>
             <a:fld id="{059A6F5A-3024-43F4-A20E-288FCAB0A2E6}" type="datetimeFigureOut">
               <a:rPr lang="en-US" smtClean="0"/>
-              <a:t>3/25/2026</a:t>
+              <a:t>3/26/2026</a:t>
             </a:fld>
             <a:endParaRPr lang="en-US"/>
           </a:p>
@@ -3152,7 +3152,7 @@
           <a:p>
             <a:fld id="{059A6F5A-3024-43F4-A20E-288FCAB0A2E6}" type="datetimeFigureOut">
               <a:rPr lang="en-US" smtClean="0"/>
-              <a:t>3/25/2026</a:t>
+              <a:t>3/26/2026</a:t>
             </a:fld>
             <a:endParaRPr lang="en-US"/>
           </a:p>
@@ -7037,6 +7037,132 @@
           </p:pic>
         </mc:Fallback>
       </mc:AlternateContent>
+      <p:sp>
+        <p:nvSpPr>
+          <p:cNvPr id="4" name="TextBox 3">
+            <a:extLst>
+              <a:ext uri="{FF2B5EF4-FFF2-40B4-BE49-F238E27FC236}">
+                <a16:creationId xmlns:a16="http://schemas.microsoft.com/office/drawing/2014/main" id="{F2135BF5-884E-A408-3B5F-CC1EFB9860FC}"/>
+              </a:ext>
+            </a:extLst>
+          </p:cNvPr>
+          <p:cNvSpPr txBox="1"/>
+          <p:nvPr/>
+        </p:nvSpPr>
+        <p:spPr>
+          <a:xfrm>
+            <a:off x="0" y="1734709"/>
+            <a:ext cx="1800421" cy="246221"/>
+          </a:xfrm>
+          <a:prstGeom prst="rect">
+            <a:avLst/>
+          </a:prstGeom>
+          <a:noFill/>
+        </p:spPr>
+        <p:txBody>
+          <a:bodyPr wrap="square" rtlCol="0">
+            <a:spAutoFit/>
+          </a:bodyPr>
+          <a:lstStyle/>
+          <a:p>
+            <a:r>
+              <a:rPr lang="en-US" sz="1000" dirty="0">
+                <a:solidFill>
+                  <a:schemeClr val="accent5">
+                    <a:lumMod val="60000"/>
+                    <a:lumOff val="40000"/>
+                  </a:schemeClr>
+                </a:solidFill>
+              </a:rPr>
+              <a:t>My authorized lines</a:t>
+            </a:r>
+          </a:p>
+        </p:txBody>
+      </p:sp>
+      <p:sp>
+        <p:nvSpPr>
+          <p:cNvPr id="5" name="TextBox 4">
+            <a:extLst>
+              <a:ext uri="{FF2B5EF4-FFF2-40B4-BE49-F238E27FC236}">
+                <a16:creationId xmlns:a16="http://schemas.microsoft.com/office/drawing/2014/main" id="{0A899819-A9DD-50A5-8C00-3DD5F86DB1E2}"/>
+              </a:ext>
+            </a:extLst>
+          </p:cNvPr>
+          <p:cNvSpPr txBox="1"/>
+          <p:nvPr/>
+        </p:nvSpPr>
+        <p:spPr>
+          <a:xfrm>
+            <a:off x="4759214" y="900356"/>
+            <a:ext cx="1800421" cy="246221"/>
+          </a:xfrm>
+          <a:prstGeom prst="rect">
+            <a:avLst/>
+          </a:prstGeom>
+          <a:noFill/>
+        </p:spPr>
+        <p:txBody>
+          <a:bodyPr wrap="square" rtlCol="0">
+            <a:spAutoFit/>
+          </a:bodyPr>
+          <a:lstStyle/>
+          <a:p>
+            <a:r>
+              <a:rPr lang="en-US" sz="1000" dirty="0">
+                <a:solidFill>
+                  <a:schemeClr val="accent5">
+                    <a:lumMod val="60000"/>
+                    <a:lumOff val="40000"/>
+                  </a:schemeClr>
+                </a:solidFill>
+              </a:rPr>
+              <a:t>The list of current lockouts</a:t>
+            </a:r>
+          </a:p>
+        </p:txBody>
+      </p:sp>
+      <p:sp>
+        <p:nvSpPr>
+          <p:cNvPr id="6" name="TextBox 5">
+            <a:extLst>
+              <a:ext uri="{FF2B5EF4-FFF2-40B4-BE49-F238E27FC236}">
+                <a16:creationId xmlns:a16="http://schemas.microsoft.com/office/drawing/2014/main" id="{0D0510F0-4AB6-839D-5408-8A58F707CA83}"/>
+              </a:ext>
+            </a:extLst>
+          </p:cNvPr>
+          <p:cNvSpPr txBox="1"/>
+          <p:nvPr/>
+        </p:nvSpPr>
+        <p:spPr>
+          <a:xfrm>
+            <a:off x="8540934" y="1047274"/>
+            <a:ext cx="2648683" cy="246221"/>
+          </a:xfrm>
+          <a:prstGeom prst="rect">
+            <a:avLst/>
+          </a:prstGeom>
+          <a:noFill/>
+        </p:spPr>
+        <p:txBody>
+          <a:bodyPr wrap="square" rtlCol="0">
+            <a:spAutoFit/>
+          </a:bodyPr>
+          <a:lstStyle/>
+          <a:p>
+            <a:r>
+              <a:rPr lang="en-US" sz="1000" dirty="0">
+                <a:solidFill>
+                  <a:schemeClr val="accent5">
+                    <a:lumMod val="60000"/>
+                    <a:lumOff val="40000"/>
+                  </a:schemeClr>
+                </a:solidFill>
+              </a:rPr>
+              <a:t>The list of attempted resets for this lockout</a:t>
+            </a:r>
+          </a:p>
+        </p:txBody>
+      </p:sp>
     </p:spTree>
     <p:extLst>
       <p:ext uri="{BB962C8B-B14F-4D97-AF65-F5344CB8AC3E}">
@@ -7069,10 +7195,10 @@
       </p:grpSpPr>
       <p:pic>
         <p:nvPicPr>
-          <p:cNvPr id="4" name="Picture 3">
-            <a:extLst>
-              <a:ext uri="{FF2B5EF4-FFF2-40B4-BE49-F238E27FC236}">
-                <a16:creationId xmlns:a16="http://schemas.microsoft.com/office/drawing/2014/main" id="{E2737D05-7133-2C5D-6738-52E3A415A52B}"/>
+          <p:cNvPr id="11" name="Picture 10">
+            <a:extLst>
+              <a:ext uri="{FF2B5EF4-FFF2-40B4-BE49-F238E27FC236}">
+                <a16:creationId xmlns:a16="http://schemas.microsoft.com/office/drawing/2014/main" id="{18978977-CA23-796D-83F1-1984F00BB595}"/>
               </a:ext>
             </a:extLst>
           </p:cNvPr>
@@ -7083,14 +7209,15 @@
         </p:nvPicPr>
         <p:blipFill>
           <a:blip r:embed="rId2"/>
+          <a:srcRect r="170"/>
           <a:stretch>
             <a:fillRect/>
           </a:stretch>
         </p:blipFill>
         <p:spPr>
           <a:xfrm>
-            <a:off x="293204" y="896378"/>
-            <a:ext cx="11546862" cy="5788568"/>
+            <a:off x="293204" y="895723"/>
+            <a:ext cx="11527321" cy="5752261"/>
           </a:xfrm>
           <a:prstGeom prst="rect">
             <a:avLst/>
@@ -7631,7 +7758,7 @@
         <p:spPr>
           <a:xfrm>
             <a:off x="11736073" y="1343024"/>
-            <a:ext cx="553998" cy="5179046"/>
+            <a:ext cx="553998" cy="5235151"/>
           </a:xfrm>
           <a:prstGeom prst="rect">
             <a:avLst/>
@@ -7653,7 +7780,7 @@
                   </a:schemeClr>
                 </a:solidFill>
               </a:rPr>
-              <a:t>When there are more results than fit on the screen,</a:t>
+              <a:t>When there are more results than fit on the screen, two scroll bars appear.</a:t>
             </a:r>
           </a:p>
           <a:p>
@@ -7666,7 +7793,7 @@
                   </a:schemeClr>
                 </a:solidFill>
               </a:rPr>
-              <a:t>use the outer one to navigate the page and the inner one to navigate the table</a:t>
+              <a:t>Use the outer one to navigate the page, and the inner one to navigate the table</a:t>
             </a:r>
           </a:p>
         </p:txBody>
@@ -7732,6 +7859,89 @@
           <a:xfrm>
             <a:off x="10412998" y="1142598"/>
             <a:ext cx="610602" cy="244457"/>
+          </a:xfrm>
+          <a:prstGeom prst="straightConnector1">
+            <a:avLst/>
+          </a:prstGeom>
+          <a:ln>
+            <a:tailEnd type="triangle"/>
+          </a:ln>
+        </p:spPr>
+        <p:style>
+          <a:lnRef idx="2">
+            <a:schemeClr val="accent1"/>
+          </a:lnRef>
+          <a:fillRef idx="0">
+            <a:schemeClr val="accent1"/>
+          </a:fillRef>
+          <a:effectRef idx="1">
+            <a:schemeClr val="accent1"/>
+          </a:effectRef>
+          <a:fontRef idx="minor">
+            <a:schemeClr val="tx1"/>
+          </a:fontRef>
+        </p:style>
+      </p:cxnSp>
+      <p:sp>
+        <p:nvSpPr>
+          <p:cNvPr id="13" name="TextBox 12">
+            <a:extLst>
+              <a:ext uri="{FF2B5EF4-FFF2-40B4-BE49-F238E27FC236}">
+                <a16:creationId xmlns:a16="http://schemas.microsoft.com/office/drawing/2014/main" id="{FF123253-2E94-9C58-7E87-EDBF51196088}"/>
+              </a:ext>
+            </a:extLst>
+          </p:cNvPr>
+          <p:cNvSpPr txBox="1"/>
+          <p:nvPr/>
+        </p:nvSpPr>
+        <p:spPr>
+          <a:xfrm>
+            <a:off x="9239858" y="2123955"/>
+            <a:ext cx="2490400" cy="246221"/>
+          </a:xfrm>
+          <a:prstGeom prst="rect">
+            <a:avLst/>
+          </a:prstGeom>
+          <a:noFill/>
+        </p:spPr>
+        <p:txBody>
+          <a:bodyPr wrap="square" rtlCol="0">
+            <a:spAutoFit/>
+          </a:bodyPr>
+          <a:lstStyle/>
+          <a:p>
+            <a:r>
+              <a:rPr lang="en-US" sz="1000" dirty="0">
+                <a:solidFill>
+                  <a:schemeClr val="accent5">
+                    <a:lumMod val="60000"/>
+                    <a:lumOff val="40000"/>
+                  </a:schemeClr>
+                </a:solidFill>
+              </a:rPr>
+              <a:t>Gray when clicking it wouldn’t do anything</a:t>
+            </a:r>
+          </a:p>
+        </p:txBody>
+      </p:sp>
+      <p:cxnSp>
+        <p:nvCxnSpPr>
+          <p:cNvPr id="19" name="Straight Arrow Connector 18">
+            <a:extLst>
+              <a:ext uri="{FF2B5EF4-FFF2-40B4-BE49-F238E27FC236}">
+                <a16:creationId xmlns:a16="http://schemas.microsoft.com/office/drawing/2014/main" id="{DA11F7E4-92B8-491F-A966-A970F77716A5}"/>
+              </a:ext>
+            </a:extLst>
+          </p:cNvPr>
+          <p:cNvCxnSpPr>
+            <a:stCxn id="13" idx="2"/>
+          </p:cNvCxnSpPr>
+          <p:nvPr/>
+        </p:nvCxnSpPr>
+        <p:spPr>
+          <a:xfrm>
+            <a:off x="10485058" y="2370176"/>
+            <a:ext cx="709992" cy="433984"/>
           </a:xfrm>
           <a:prstGeom prst="straightConnector1">
             <a:avLst/>
@@ -7793,10 +8003,10 @@
       </p:grpSpPr>
       <p:pic>
         <p:nvPicPr>
-          <p:cNvPr id="5" name="Picture 4">
-            <a:extLst>
-              <a:ext uri="{FF2B5EF4-FFF2-40B4-BE49-F238E27FC236}">
-                <a16:creationId xmlns:a16="http://schemas.microsoft.com/office/drawing/2014/main" id="{97DFF277-3D7C-8B60-B6AC-9A6246A62CB6}"/>
+          <p:cNvPr id="4" name="Picture 3">
+            <a:extLst>
+              <a:ext uri="{FF2B5EF4-FFF2-40B4-BE49-F238E27FC236}">
+                <a16:creationId xmlns:a16="http://schemas.microsoft.com/office/drawing/2014/main" id="{F3D1F6DA-24FA-8E5E-C59F-4298021AF012}"/>
               </a:ext>
             </a:extLst>
           </p:cNvPr>
@@ -7814,7 +8024,7 @@
         <p:spPr>
           <a:xfrm>
             <a:off x="301657" y="932859"/>
-            <a:ext cx="11585543" cy="5795807"/>
+            <a:ext cx="11615966" cy="5795807"/>
           </a:xfrm>
           <a:prstGeom prst="rect">
             <a:avLst/>
@@ -7865,7 +8075,7 @@
         </p:nvSpPr>
         <p:spPr>
           <a:xfrm>
-            <a:off x="5032528" y="2966192"/>
+            <a:off x="5032528" y="3228945"/>
             <a:ext cx="4559341" cy="400110"/>
           </a:xfrm>
           <a:prstGeom prst="rect">
@@ -7907,7 +8117,7 @@
         </p:nvSpPr>
         <p:spPr>
           <a:xfrm>
-            <a:off x="7594754" y="2426185"/>
+            <a:off x="7462779" y="2796914"/>
             <a:ext cx="3187546" cy="400110"/>
           </a:xfrm>
           <a:prstGeom prst="rect">
@@ -7949,7 +8159,7 @@
         </p:nvSpPr>
         <p:spPr>
           <a:xfrm>
-            <a:off x="1995135" y="2398582"/>
+            <a:off x="2050345" y="2735359"/>
             <a:ext cx="2465740" cy="461665"/>
           </a:xfrm>
           <a:prstGeom prst="rect">
@@ -7991,7 +8201,7 @@
         </p:nvSpPr>
         <p:spPr>
           <a:xfrm>
-            <a:off x="4516085" y="2398582"/>
+            <a:off x="4516085" y="2753380"/>
             <a:ext cx="2465740" cy="461665"/>
           </a:xfrm>
           <a:prstGeom prst="rect">
@@ -8015,6 +8225,129 @@
                 </a:solidFill>
               </a:rPr>
               <a:t>11:59 PM to include day, 12 AM to exclude (same as reset before)</a:t>
+            </a:r>
+          </a:p>
+        </p:txBody>
+      </p:sp>
+      <p:sp>
+        <p:nvSpPr>
+          <p:cNvPr id="11" name="TextBox 10">
+            <a:extLst>
+              <a:ext uri="{FF2B5EF4-FFF2-40B4-BE49-F238E27FC236}">
+                <a16:creationId xmlns:a16="http://schemas.microsoft.com/office/drawing/2014/main" id="{2159A429-2F1C-78A6-20C5-FB8B65EBE026}"/>
+              </a:ext>
+            </a:extLst>
+          </p:cNvPr>
+          <p:cNvSpPr txBox="1"/>
+          <p:nvPr/>
+        </p:nvSpPr>
+        <p:spPr>
+          <a:xfrm>
+            <a:off x="9894829" y="2192107"/>
+            <a:ext cx="1897121" cy="246221"/>
+          </a:xfrm>
+          <a:prstGeom prst="rect">
+            <a:avLst/>
+          </a:prstGeom>
+          <a:noFill/>
+        </p:spPr>
+        <p:txBody>
+          <a:bodyPr wrap="square" rtlCol="0">
+            <a:spAutoFit/>
+          </a:bodyPr>
+          <a:lstStyle/>
+          <a:p>
+            <a:r>
+              <a:rPr lang="en-US" sz="1000" dirty="0">
+                <a:solidFill>
+                  <a:schemeClr val="accent5">
+                    <a:lumMod val="60000"/>
+                    <a:lumOff val="40000"/>
+                  </a:schemeClr>
+                </a:solidFill>
+              </a:rPr>
+              <a:t>Blue when ready to be pressed</a:t>
+            </a:r>
+          </a:p>
+        </p:txBody>
+      </p:sp>
+      <p:cxnSp>
+        <p:nvCxnSpPr>
+          <p:cNvPr id="13" name="Straight Arrow Connector 12">
+            <a:extLst>
+              <a:ext uri="{FF2B5EF4-FFF2-40B4-BE49-F238E27FC236}">
+                <a16:creationId xmlns:a16="http://schemas.microsoft.com/office/drawing/2014/main" id="{BF974435-DF8A-2A54-C8FC-3B31B3623C7D}"/>
+              </a:ext>
+            </a:extLst>
+          </p:cNvPr>
+          <p:cNvCxnSpPr/>
+          <p:nvPr/>
+        </p:nvCxnSpPr>
+        <p:spPr>
+          <a:xfrm>
+            <a:off x="10845800" y="2444750"/>
+            <a:ext cx="387350" cy="419100"/>
+          </a:xfrm>
+          <a:prstGeom prst="straightConnector1">
+            <a:avLst/>
+          </a:prstGeom>
+          <a:ln>
+            <a:tailEnd type="triangle"/>
+          </a:ln>
+        </p:spPr>
+        <p:style>
+          <a:lnRef idx="2">
+            <a:schemeClr val="accent1"/>
+          </a:lnRef>
+          <a:fillRef idx="0">
+            <a:schemeClr val="accent1"/>
+          </a:fillRef>
+          <a:effectRef idx="1">
+            <a:schemeClr val="accent1"/>
+          </a:effectRef>
+          <a:fontRef idx="minor">
+            <a:schemeClr val="tx1"/>
+          </a:fontRef>
+        </p:style>
+      </p:cxnSp>
+      <p:sp>
+        <p:nvSpPr>
+          <p:cNvPr id="14" name="TextBox 13">
+            <a:extLst>
+              <a:ext uri="{FF2B5EF4-FFF2-40B4-BE49-F238E27FC236}">
+                <a16:creationId xmlns:a16="http://schemas.microsoft.com/office/drawing/2014/main" id="{7DC3F017-64CA-EE8E-8C22-82FB3595FEB4}"/>
+              </a:ext>
+            </a:extLst>
+          </p:cNvPr>
+          <p:cNvSpPr txBox="1"/>
+          <p:nvPr/>
+        </p:nvSpPr>
+        <p:spPr>
+          <a:xfrm>
+            <a:off x="3015545" y="1292993"/>
+            <a:ext cx="1500540" cy="246221"/>
+          </a:xfrm>
+          <a:prstGeom prst="rect">
+            <a:avLst/>
+          </a:prstGeom>
+          <a:noFill/>
+        </p:spPr>
+        <p:txBody>
+          <a:bodyPr wrap="square" rtlCol="0">
+            <a:spAutoFit/>
+          </a:bodyPr>
+          <a:lstStyle/>
+          <a:p>
+            <a:r>
+              <a:rPr lang="en-US" sz="1000" dirty="0">
+                <a:solidFill>
+                  <a:schemeClr val="accent5">
+                    <a:lumMod val="60000"/>
+                    <a:lumOff val="40000"/>
+                  </a:schemeClr>
+                </a:solidFill>
+              </a:rPr>
+              <a:t>To remind you to search</a:t>
             </a:r>
           </a:p>
         </p:txBody>
@@ -8057,10 +8390,10 @@
       </p:grpSpPr>
       <p:pic>
         <p:nvPicPr>
-          <p:cNvPr id="6" name="Picture 5">
-            <a:extLst>
-              <a:ext uri="{FF2B5EF4-FFF2-40B4-BE49-F238E27FC236}">
-                <a16:creationId xmlns:a16="http://schemas.microsoft.com/office/drawing/2014/main" id="{43D24C7C-13B5-1A56-121B-9EDEDD100422}"/>
+          <p:cNvPr id="7" name="Picture 6">
+            <a:extLst>
+              <a:ext uri="{FF2B5EF4-FFF2-40B4-BE49-F238E27FC236}">
+                <a16:creationId xmlns:a16="http://schemas.microsoft.com/office/drawing/2014/main" id="{6D6F8B15-E5E0-29A0-C036-A403B0BF4814}"/>
               </a:ext>
             </a:extLst>
           </p:cNvPr>
@@ -8077,8 +8410,8 @@
         </p:blipFill>
         <p:spPr>
           <a:xfrm>
-            <a:off x="278342" y="907749"/>
-            <a:ext cx="11486310" cy="5725095"/>
+            <a:off x="278342" y="905060"/>
+            <a:ext cx="11432187" cy="5725095"/>
           </a:xfrm>
           <a:prstGeom prst="rect">
             <a:avLst/>
@@ -8129,7 +8462,7 @@
         </p:nvSpPr>
         <p:spPr>
           <a:xfrm>
-            <a:off x="1729361" y="2845355"/>
+            <a:off x="1756950" y="1665715"/>
             <a:ext cx="1904682" cy="246221"/>
           </a:xfrm>
           <a:prstGeom prst="rect">
@@ -8171,7 +8504,7 @@
         </p:nvSpPr>
         <p:spPr>
           <a:xfrm>
-            <a:off x="3634043" y="2968465"/>
+            <a:off x="3661632" y="1772874"/>
             <a:ext cx="762442" cy="400110"/>
           </a:xfrm>
           <a:prstGeom prst="rect">
@@ -8213,7 +8546,7 @@
         </p:nvSpPr>
         <p:spPr>
           <a:xfrm>
-            <a:off x="9452168" y="2845354"/>
+            <a:off x="9332247" y="1649764"/>
             <a:ext cx="1470274" cy="246221"/>
           </a:xfrm>
           <a:prstGeom prst="rect">
@@ -8255,7 +8588,7 @@
         </p:nvSpPr>
         <p:spPr>
           <a:xfrm>
-            <a:off x="4516406" y="2968466"/>
+            <a:off x="4516406" y="1711881"/>
             <a:ext cx="4815841" cy="400110"/>
           </a:xfrm>
           <a:prstGeom prst="rect">
@@ -8321,6 +8654,90 @@
                 </a:solidFill>
               </a:rPr>
               <a:t>Sorting assumes you only want to see entries where that value exists. For example, sorting by reset time here would hide all entries except the ones reset by ‘b’ and ‘eh’, then apply the sort</a:t>
+            </a:r>
+          </a:p>
+        </p:txBody>
+      </p:sp>
+      <p:sp>
+        <p:nvSpPr>
+          <p:cNvPr id="8" name="TextBox 7">
+            <a:extLst>
+              <a:ext uri="{FF2B5EF4-FFF2-40B4-BE49-F238E27FC236}">
+                <a16:creationId xmlns:a16="http://schemas.microsoft.com/office/drawing/2014/main" id="{38C0F6C5-CFB1-6CC7-120C-A60C2E6998E2}"/>
+              </a:ext>
+            </a:extLst>
+          </p:cNvPr>
+          <p:cNvSpPr txBox="1"/>
+          <p:nvPr/>
+        </p:nvSpPr>
+        <p:spPr>
+          <a:xfrm>
+            <a:off x="2839624" y="1242804"/>
+            <a:ext cx="2164175" cy="246221"/>
+          </a:xfrm>
+          <a:prstGeom prst="rect">
+            <a:avLst/>
+          </a:prstGeom>
+          <a:noFill/>
+        </p:spPr>
+        <p:txBody>
+          <a:bodyPr wrap="square" rtlCol="0">
+            <a:spAutoFit/>
+          </a:bodyPr>
+          <a:lstStyle/>
+          <a:p>
+            <a:r>
+              <a:rPr lang="en-US" sz="1000" dirty="0">
+                <a:solidFill>
+                  <a:schemeClr val="accent5">
+                    <a:lumMod val="60000"/>
+                    <a:lumOff val="40000"/>
+                  </a:schemeClr>
+                </a:solidFill>
+              </a:rPr>
+              <a:t>To remind you this is a filtered table</a:t>
+            </a:r>
+          </a:p>
+        </p:txBody>
+      </p:sp>
+      <p:sp>
+        <p:nvSpPr>
+          <p:cNvPr id="9" name="TextBox 8">
+            <a:extLst>
+              <a:ext uri="{FF2B5EF4-FFF2-40B4-BE49-F238E27FC236}">
+                <a16:creationId xmlns:a16="http://schemas.microsoft.com/office/drawing/2014/main" id="{957F113F-74A2-D03A-CE83-2E6DEE75383A}"/>
+              </a:ext>
+            </a:extLst>
+          </p:cNvPr>
+          <p:cNvSpPr txBox="1"/>
+          <p:nvPr/>
+        </p:nvSpPr>
+        <p:spPr>
+          <a:xfrm>
+            <a:off x="9884099" y="1053754"/>
+            <a:ext cx="1598515" cy="246221"/>
+          </a:xfrm>
+          <a:prstGeom prst="rect">
+            <a:avLst/>
+          </a:prstGeom>
+          <a:noFill/>
+        </p:spPr>
+        <p:txBody>
+          <a:bodyPr wrap="none" rtlCol="0">
+            <a:spAutoFit/>
+          </a:bodyPr>
+          <a:lstStyle/>
+          <a:p>
+            <a:r>
+              <a:rPr lang="en-US" sz="1000" dirty="0">
+                <a:solidFill>
+                  <a:schemeClr val="accent5">
+                    <a:lumMod val="60000"/>
+                    <a:lumOff val="40000"/>
+                  </a:schemeClr>
+                </a:solidFill>
+              </a:rPr>
+              <a:t>Auto-collapses on search</a:t>
             </a:r>
           </a:p>
         </p:txBody>
@@ -8363,10 +8780,10 @@
       </p:grpSpPr>
       <p:pic>
         <p:nvPicPr>
-          <p:cNvPr id="8" name="Picture 7">
-            <a:extLst>
-              <a:ext uri="{FF2B5EF4-FFF2-40B4-BE49-F238E27FC236}">
-                <a16:creationId xmlns:a16="http://schemas.microsoft.com/office/drawing/2014/main" id="{C462799C-5083-1D2B-1656-A30074633406}"/>
+          <p:cNvPr id="4" name="Picture 3">
+            <a:extLst>
+              <a:ext uri="{FF2B5EF4-FFF2-40B4-BE49-F238E27FC236}">
+                <a16:creationId xmlns:a16="http://schemas.microsoft.com/office/drawing/2014/main" id="{74511EC7-A405-0579-A8E2-20E6591ECBAA}"/>
               </a:ext>
             </a:extLst>
           </p:cNvPr>
@@ -8384,7 +8801,7 @@
         <p:spPr>
           <a:xfrm>
             <a:off x="295274" y="902009"/>
-            <a:ext cx="11591925" cy="5777718"/>
+            <a:ext cx="11591925" cy="5820341"/>
           </a:xfrm>
           <a:prstGeom prst="rect">
             <a:avLst/>
@@ -8477,7 +8894,7 @@
         </p:nvSpPr>
         <p:spPr>
           <a:xfrm>
-            <a:off x="8150368" y="3028890"/>
+            <a:off x="8150368" y="902009"/>
             <a:ext cx="3659854" cy="400110"/>
           </a:xfrm>
           <a:prstGeom prst="rect">
@@ -8519,7 +8936,7 @@
         </p:nvSpPr>
         <p:spPr>
           <a:xfrm>
-            <a:off x="9248140" y="3429000"/>
+            <a:off x="8699254" y="1874520"/>
             <a:ext cx="2562082" cy="400110"/>
           </a:xfrm>
           <a:prstGeom prst="rect">
@@ -8585,10 +9002,10 @@
       </p:grpSpPr>
       <p:pic>
         <p:nvPicPr>
-          <p:cNvPr id="4" name="Picture 3">
-            <a:extLst>
-              <a:ext uri="{FF2B5EF4-FFF2-40B4-BE49-F238E27FC236}">
-                <a16:creationId xmlns:a16="http://schemas.microsoft.com/office/drawing/2014/main" id="{36EB9BAC-B30D-BF7B-9220-CC72F601E613}"/>
+          <p:cNvPr id="6" name="Picture 5">
+            <a:extLst>
+              <a:ext uri="{FF2B5EF4-FFF2-40B4-BE49-F238E27FC236}">
+                <a16:creationId xmlns:a16="http://schemas.microsoft.com/office/drawing/2014/main" id="{603CEC4F-063E-A6A5-DB9A-4633ABDFF880}"/>
               </a:ext>
             </a:extLst>
           </p:cNvPr>
@@ -8605,8 +9022,8 @@
         </p:blipFill>
         <p:spPr>
           <a:xfrm>
-            <a:off x="301658" y="905061"/>
-            <a:ext cx="11640690" cy="5774612"/>
+            <a:off x="301658" y="902703"/>
+            <a:ext cx="11640690" cy="5841687"/>
           </a:xfrm>
           <a:prstGeom prst="rect">
             <a:avLst/>
@@ -8657,7 +9074,7 @@
         </p:nvSpPr>
         <p:spPr>
           <a:xfrm>
-            <a:off x="4438650" y="2406650"/>
+            <a:off x="4438650" y="2759073"/>
             <a:ext cx="4495654" cy="276999"/>
           </a:xfrm>
           <a:prstGeom prst="rect">
@@ -8699,7 +9116,7 @@
         </p:nvSpPr>
         <p:spPr>
           <a:xfrm>
-            <a:off x="2584580" y="1835150"/>
+            <a:off x="2584580" y="1696648"/>
             <a:ext cx="1911421" cy="276999"/>
           </a:xfrm>
           <a:prstGeom prst="rect">
@@ -8741,7 +9158,7 @@
         </p:nvSpPr>
         <p:spPr>
           <a:xfrm>
-            <a:off x="5320607" y="1835149"/>
+            <a:off x="5615058" y="1693568"/>
             <a:ext cx="2736134" cy="276999"/>
           </a:xfrm>
           <a:prstGeom prst="rect">
@@ -8783,7 +9200,7 @@
         </p:nvSpPr>
         <p:spPr>
           <a:xfrm>
-            <a:off x="8502089" y="1835148"/>
+            <a:off x="8934304" y="1693567"/>
             <a:ext cx="1921295" cy="276999"/>
           </a:xfrm>
           <a:prstGeom prst="rect">
@@ -8825,7 +9242,7 @@
         </p:nvSpPr>
         <p:spPr>
           <a:xfrm>
-            <a:off x="7432643" y="3050323"/>
+            <a:off x="7357229" y="3409226"/>
             <a:ext cx="2665281" cy="276999"/>
           </a:xfrm>
           <a:prstGeom prst="rect">

</xml_diff>